<commit_message>
Quitar los diseños saturados del tema 6 y agregar los libros de medición
- Fraccionados 2^(k−p): sobre la versión compactada (112), se eliminan las
  diapositivas de diseños saturados; queda una sola del 2^(7−4)_III como
  base del doblez. 106 diapositivas y guía regenerada.
- Trabajo práctico: script build_medicion_xlsx.py y tres libros de Excel
  (5, 6 y 7 A) con 9 réplicas, posiciones fijas de 0 a 210 µm, registro de
  tiempos por corrida y prueba t contra τ0.
- Bitácora del 27 y 28 de octubre.

Co-Authored-By: Claude Opus 5.5 <noreply@anthropic.com>
</commit_message>
<xml_diff>
--- a/trabajo-practico/protocolo/Protocolo_Experimentacion_Por_Nivel.pptx
+++ b/trabajo-practico/protocolo/Protocolo_Experimentacion_Por_Nivel.pptx
@@ -1210,7 +1210,7 @@
           <a:p>
             <a:fld id="{5BCAD085-E8A6-8845-BD4E-CB4CCA059FC4}" type="datetimeFigureOut">
               <a:rPr lang="en-US" smtClean="0"/>
-              <a:t>10/26/2026</a:t>
+              <a:t>10/27/2026</a:t>
             </a:fld>
             <a:endParaRPr lang="en-US"/>
           </a:p>
@@ -1378,7 +1378,7 @@
           <a:p>
             <a:fld id="{5BCAD085-E8A6-8845-BD4E-CB4CCA059FC4}" type="datetimeFigureOut">
               <a:rPr lang="en-US" smtClean="0"/>
-              <a:t>10/26/2026</a:t>
+              <a:t>10/27/2026</a:t>
             </a:fld>
             <a:endParaRPr lang="en-US"/>
           </a:p>
@@ -1556,7 +1556,7 @@
           <a:p>
             <a:fld id="{5BCAD085-E8A6-8845-BD4E-CB4CCA059FC4}" type="datetimeFigureOut">
               <a:rPr lang="en-US" smtClean="0"/>
-              <a:t>10/26/2026</a:t>
+              <a:t>10/27/2026</a:t>
             </a:fld>
             <a:endParaRPr lang="en-US"/>
           </a:p>
@@ -1724,7 +1724,7 @@
           <a:p>
             <a:fld id="{5BCAD085-E8A6-8845-BD4E-CB4CCA059FC4}" type="datetimeFigureOut">
               <a:rPr lang="en-US" smtClean="0"/>
-              <a:t>10/26/2026</a:t>
+              <a:t>10/27/2026</a:t>
             </a:fld>
             <a:endParaRPr lang="en-US"/>
           </a:p>
@@ -1969,7 +1969,7 @@
           <a:p>
             <a:fld id="{5BCAD085-E8A6-8845-BD4E-CB4CCA059FC4}" type="datetimeFigureOut">
               <a:rPr lang="en-US" smtClean="0"/>
-              <a:t>10/26/2026</a:t>
+              <a:t>10/27/2026</a:t>
             </a:fld>
             <a:endParaRPr lang="en-US"/>
           </a:p>
@@ -2254,7 +2254,7 @@
           <a:p>
             <a:fld id="{5BCAD085-E8A6-8845-BD4E-CB4CCA059FC4}" type="datetimeFigureOut">
               <a:rPr lang="en-US" smtClean="0"/>
-              <a:t>10/26/2026</a:t>
+              <a:t>10/27/2026</a:t>
             </a:fld>
             <a:endParaRPr lang="en-US"/>
           </a:p>
@@ -2673,7 +2673,7 @@
           <a:p>
             <a:fld id="{5BCAD085-E8A6-8845-BD4E-CB4CCA059FC4}" type="datetimeFigureOut">
               <a:rPr lang="en-US" smtClean="0"/>
-              <a:t>10/26/2026</a:t>
+              <a:t>10/27/2026</a:t>
             </a:fld>
             <a:endParaRPr lang="en-US"/>
           </a:p>
@@ -2790,7 +2790,7 @@
           <a:p>
             <a:fld id="{5BCAD085-E8A6-8845-BD4E-CB4CCA059FC4}" type="datetimeFigureOut">
               <a:rPr lang="en-US" smtClean="0"/>
-              <a:t>10/26/2026</a:t>
+              <a:t>10/27/2026</a:t>
             </a:fld>
             <a:endParaRPr lang="en-US"/>
           </a:p>
@@ -2885,7 +2885,7 @@
           <a:p>
             <a:fld id="{5BCAD085-E8A6-8845-BD4E-CB4CCA059FC4}" type="datetimeFigureOut">
               <a:rPr lang="en-US" smtClean="0"/>
-              <a:t>10/26/2026</a:t>
+              <a:t>10/27/2026</a:t>
             </a:fld>
             <a:endParaRPr lang="en-US"/>
           </a:p>
@@ -3160,7 +3160,7 @@
           <a:p>
             <a:fld id="{5BCAD085-E8A6-8845-BD4E-CB4CCA059FC4}" type="datetimeFigureOut">
               <a:rPr lang="en-US" smtClean="0"/>
-              <a:t>10/26/2026</a:t>
+              <a:t>10/27/2026</a:t>
             </a:fld>
             <a:endParaRPr lang="en-US"/>
           </a:p>
@@ -3412,7 +3412,7 @@
           <a:p>
             <a:fld id="{5BCAD085-E8A6-8845-BD4E-CB4CCA059FC4}" type="datetimeFigureOut">
               <a:rPr lang="en-US" smtClean="0"/>
-              <a:t>10/26/2026</a:t>
+              <a:t>10/27/2026</a:t>
             </a:fld>
             <a:endParaRPr lang="en-US"/>
           </a:p>
@@ -3623,7 +3623,7 @@
           <a:p>
             <a:fld id="{5BCAD085-E8A6-8845-BD4E-CB4CCA059FC4}" type="datetimeFigureOut">
               <a:rPr lang="en-US" smtClean="0"/>
-              <a:t>10/26/2026</a:t>
+              <a:t>10/27/2026</a:t>
             </a:fld>
             <a:endParaRPr lang="en-US"/>
           </a:p>
@@ -7948,8 +7948,8 @@
         </p:nvSpPr>
         <p:spPr>
           <a:xfrm>
-            <a:off x="6492240" y="2514600"/>
-            <a:ext cx="4965192" cy="822960"/>
+            <a:off x="6492240" y="2592655"/>
+            <a:ext cx="4965192" cy="666849"/>
           </a:xfrm>
           <a:prstGeom prst="rect">
             <a:avLst/>
@@ -7968,14 +7968,29 @@
               </a:spcAft>
             </a:pPr>
             <a:r>
-              <a:rPr sz="2000" b="0" i="0">
+              <a:rPr sz="2000" b="0" i="0" dirty="0">
                 <a:solidFill>
                   <a:srgbClr val="0E1726"/>
                 </a:solidFill>
                 <a:latin typeface="Cambria Math"/>
               </a:rPr>
-              <a:t>Caso 2 · t de una muestra</a:t>
-            </a:r>
+              <a:t>Caso 2 · t de una </a:t>
+            </a:r>
+            <a:r>
+              <a:rPr sz="2000" b="0" i="0" dirty="0" err="1">
+                <a:solidFill>
+                  <a:srgbClr val="0E1726"/>
+                </a:solidFill>
+                <a:latin typeface="Cambria Math"/>
+              </a:rPr>
+              <a:t>muestra</a:t>
+            </a:r>
+            <a:endParaRPr sz="2000" b="0" i="0" dirty="0">
+              <a:solidFill>
+                <a:srgbClr val="0E1726"/>
+              </a:solidFill>
+              <a:latin typeface="Cambria Math"/>
+            </a:endParaRPr>
           </a:p>
           <a:p>
             <a:pPr algn="ctr">
@@ -7984,25 +7999,34 @@
               </a:spcAft>
             </a:pPr>
             <a:r>
-              <a:rPr sz="2000" b="0" i="0">
+              <a:rPr sz="2000" b="0" i="0" dirty="0">
                 <a:solidFill>
                   <a:srgbClr val="0E1726"/>
                 </a:solidFill>
                 <a:latin typeface="Cambria Math"/>
               </a:rPr>
-              <a:t>t₀ = (ȳ</a:t>
-            </a:r>
-            <a:r>
-              <a:rPr sz="2000" b="0" i="0" baseline="-25000">
+              <a:t>t₀ = (</a:t>
+            </a:r>
+            <a:r>
+              <a:rPr sz="2000" b="0" i="0" dirty="0" err="1">
                 <a:solidFill>
                   <a:srgbClr val="0E1726"/>
                 </a:solidFill>
                 <a:latin typeface="Cambria Math"/>
               </a:rPr>
+              <a:t>ȳ</a:t>
+            </a:r>
+            <a:r>
+              <a:rPr sz="2000" b="0" i="0" baseline="-25000" dirty="0" err="1">
+                <a:solidFill>
+                  <a:srgbClr val="0E1726"/>
+                </a:solidFill>
+                <a:latin typeface="Cambria Math"/>
+              </a:rPr>
               <a:t>k</a:t>
             </a:r>
             <a:r>
-              <a:rPr sz="2000" b="0" i="0">
+              <a:rPr sz="2000" b="0" i="0" dirty="0">
                 <a:solidFill>
                   <a:srgbClr val="0E1726"/>
                 </a:solidFill>
@@ -8011,7 +8035,7 @@
               <a:t> − τ</a:t>
             </a:r>
             <a:r>
-              <a:rPr sz="2000" b="0" i="0" baseline="-25000">
+              <a:rPr sz="2000" b="0" i="0" baseline="-25000" dirty="0">
                 <a:solidFill>
                   <a:srgbClr val="0E1726"/>
                 </a:solidFill>
@@ -8020,41 +8044,47 @@
               <a:t>0,k</a:t>
             </a:r>
             <a:r>
-              <a:rPr sz="2000" b="0" i="0">
+              <a:rPr sz="2000" b="0" i="0" dirty="0">
                 <a:solidFill>
                   <a:srgbClr val="0E1726"/>
                 </a:solidFill>
                 <a:latin typeface="Cambria Math"/>
               </a:rPr>
-              <a:t>) / (S</a:t>
-            </a:r>
-            <a:r>
-              <a:rPr sz="2000" b="0" i="0" baseline="-25000">
+              <a:t>) / (</a:t>
+            </a:r>
+            <a:r>
+              <a:rPr sz="2000" b="0" i="0" dirty="0" err="1">
                 <a:solidFill>
                   <a:srgbClr val="0E1726"/>
                 </a:solidFill>
                 <a:latin typeface="Cambria Math"/>
               </a:rPr>
+              <a:t>S</a:t>
+            </a:r>
+            <a:r>
+              <a:rPr sz="2000" b="0" i="0" baseline="-25000" dirty="0" err="1">
+                <a:solidFill>
+                  <a:srgbClr val="0E1726"/>
+                </a:solidFill>
+                <a:latin typeface="Cambria Math"/>
+              </a:rPr>
               <a:t>k</a:t>
             </a:r>
             <a:r>
-              <a:rPr sz="2000" b="0" i="0">
+              <a:rPr sz="2000" b="0" i="0" dirty="0">
                 <a:solidFill>
                   <a:srgbClr val="0E1726"/>
                 </a:solidFill>
                 <a:latin typeface="Cambria Math"/>
               </a:rPr>
-              <a:t>/√n) · t</a:t>
-            </a:r>
-            <a:r>
-              <a:rPr sz="2000" b="0" i="0" baseline="-25000">
-                <a:solidFill>
-                  <a:srgbClr val="0E1726"/>
-                </a:solidFill>
-                <a:latin typeface="Cambria Math"/>
-              </a:rPr>
-              <a:t>n−1</a:t>
-            </a:r>
+              <a:t>/√n) </a:t>
+            </a:r>
+            <a:endParaRPr sz="2000" b="0" i="0" baseline="-25000" dirty="0">
+              <a:solidFill>
+                <a:srgbClr val="0E1726"/>
+              </a:solidFill>
+              <a:latin typeface="Cambria Math"/>
+            </a:endParaRPr>
           </a:p>
         </p:txBody>
       </p:sp>

</xml_diff>